<commit_message>
feat: scale book to 510 customers
Generated with [Snowflake CoCo](https://docs.snowflake.com/en/user-guide/cortex-code/cortex-code)

Co-authored-by: Snowflake CoCo <noreply@snowflake.com>
</commit_message>
<xml_diff>
--- a/deck/Customer360_Decisioning_Platform_Snowflake.pptx
+++ b/deck/Customer360_Decisioning_Platform_Snowflake.pptx
@@ -308,7 +308,7 @@
                 </a:solidFill>
                 <a:latin typeface="Arial"/>
               </a:rPr>
-              <a:t>Where the 184 signals come from</a:t>
+              <a:t>Where the 2,796 signals come from</a:t>
             </a:r>
           </a:p>
         </c:rich>
@@ -369,13 +369,13 @@
                 <c:formatCode>General</c:formatCode>
                 <c:ptCount val="3"/>
                 <c:pt idx="0">
-                  <c:v>82</c:v>
+                  <c:v>1078</c:v>
                 </c:pt>
                 <c:pt idx="1">
-                  <c:v>6</c:v>
+                  <c:v>0</c:v>
                 </c:pt>
                 <c:pt idx="2">
-                  <c:v>5</c:v>
+                  <c:v>167</c:v>
                 </c:pt>
               </c:numCache>
             </c:numRef>
@@ -429,19 +429,20 @@
                 <c:formatCode>General</c:formatCode>
                 <c:ptCount val="3"/>
                 <c:pt idx="0">
-                  <c:v>31</c:v>
+                  <c:v>424</c:v>
                 </c:pt>
                 <c:pt idx="1">
-                  <c:v>15</c:v>
+                  <c:v>325</c:v>
                 </c:pt>
                 <c:pt idx="2">
-                  <c:v>45</c:v>
+                  <c:v>802</c:v>
                 </c:pt>
               </c:numCache>
             </c:numRef>
           </c:val>
         </c:ser>
         <c:dLbls>
+          <c:numFmt formatCode="#,##0;;" sourceLinked="0"/>
           <c:txPr>
             <a:bodyPr/>
             <a:lstStyle/>
@@ -9526,7 +9527,7 @@
                 </a:solidFill>
                 <a:latin typeface="Arial"/>
               </a:rPr>
-              <a:t>A small, high-quality Indian dataset. Dynamic Tables keep it current; a semantic view gives everyone the same definitions.</a:t>
+              <a:t>510 Indian customers. Dynamic Tables keep it current; a semantic view gives everyone the same definitions.</a:t>
             </a:r>
           </a:p>
         </p:txBody>
@@ -27347,7 +27348,7 @@
                 </a:solidFill>
                 <a:latin typeface="Arial"/>
               </a:rPr>
-              <a:t>93 of 184</a:t>
+              <a:t>1,245</a:t>
             </a:r>
           </a:p>
         </p:txBody>
@@ -27382,7 +27383,7 @@
                 </a:solidFill>
                 <a:latin typeface="Arial"/>
               </a:rPr>
-              <a:t>signals come only from what customers said, invisible to structured systems</a:t>
+              <a:t>of 2,796 signals come only from what customers said, invisible to structured systems</a:t>
             </a:r>
           </a:p>
         </p:txBody>
@@ -27463,7 +27464,7 @@
                 </a:solidFill>
                 <a:latin typeface="Arial"/>
               </a:rPr>
-              <a:t>5</a:t>
+              <a:t>38</a:t>
             </a:r>
           </a:p>
         </p:txBody>
@@ -27498,7 +27499,7 @@
                 </a:solidFill>
                 <a:latin typeface="Arial"/>
               </a:rPr>
-              <a:t>customers caught who had fallen through the gaps</a:t>
+              <a:t>at-risk customers caught only from what they said, with nothing in their records</a:t>
             </a:r>
           </a:p>
         </p:txBody>
@@ -27579,7 +27580,7 @@
                 </a:solidFill>
                 <a:latin typeface="Arial"/>
               </a:rPr>
-              <a:t>~1 sec</a:t>
+              <a:t>~2 sec</a:t>
             </a:r>
           </a:p>
         </p:txBody>
@@ -27614,7 +27615,7 @@
                 </a:solidFill>
                 <a:latin typeface="Arial"/>
               </a:rPr>
-              <a:t>to rank every customer into today's worklist</a:t>
+              <a:t>to rank all 510 customers into today's worklist</a:t>
             </a:r>
           </a:p>
         </p:txBody>
@@ -43602,7 +43603,7 @@
                 </a:solidFill>
                 <a:latin typeface="Arial"/>
               </a:rPr>
-              <a:t>30</a:t>
+              <a:t>510</a:t>
             </a:r>
           </a:p>
         </p:txBody>
@@ -43834,7 +43835,7 @@
                 </a:solidFill>
                 <a:latin typeface="Arial"/>
               </a:rPr>
-              <a:t>184</a:t>
+              <a:t>2,796</a:t>
             </a:r>
           </a:p>
         </p:txBody>

</xml_diff>

<commit_message>
feat: coco subagents mvp
Generated with [Snowflake CoCo](https://docs.snowflake.com/en/user-guide/cortex-code/cortex-code)

Co-authored-by: Snowflake CoCo <noreply@snowflake.com>
</commit_message>
<xml_diff>
--- a/deck/Customer360_Decisioning_Platform_Snowflake.pptx
+++ b/deck/Customer360_Decisioning_Platform_Snowflake.pptx
@@ -27,6 +27,8 @@
     <p:sldId id="277" r:id="rId31"/>
     <p:sldId id="278" r:id="rId32"/>
     <p:sldId id="279" r:id="rId33"/>
+    <p:sldId id="280" r:id="rId34"/>
+    <p:sldId id="281" r:id="rId35"/>
     <p:sldId id="261" r:id="rId11"/>
   </p:sldIdLst>
   <p:sldSz cy="5143500" cx="9144000"/>
@@ -10427,7 +10429,7 @@
                 </a:solidFill>
                 <a:latin typeface="Arial"/>
               </a:rPr>
-              <a:t>We added Service Recovery to the working platform. Nothing that already existed changed.</a:t>
+              <a:t>We added Service Recovery by hand. Because it's configuration, CoCo now builds the next one from a brief.</a:t>
             </a:r>
           </a:p>
         </p:txBody>
@@ -11290,7 +11292,7 @@
                 </a:solidFill>
                 <a:latin typeface="Arial"/>
               </a:rPr>
-              <a:t>CoCo CLI seeded the data, built the platform, and publishes four reusable skills to Snowflake for any team.</a:t>
+              <a:t>CoCo CLI seeded the data, built the platform, and publishes five skills and five subagents for any team.</a:t>
             </a:r>
           </a:p>
         </p:txBody>
@@ -11328,6 +11330,1036 @@
 </file>
 
 <file path=ppt/slides/slide17.xml><?xml version="1.0" encoding="utf-8"?>
+<p:sld xmlns:a="http://schemas.openxmlformats.org/drawingml/2006/main" xmlns:p="http://schemas.openxmlformats.org/presentationml/2006/main" xmlns:r="http://schemas.openxmlformats.org/officeDocument/2006/relationships">
+  <p:cSld>
+    <p:spTree>
+      <p:nvGrpSpPr>
+        <p:cNvPr id="1" name=""/>
+        <p:cNvGrpSpPr/>
+        <p:nvPr/>
+      </p:nvGrpSpPr>
+      <p:grpSpPr/>
+      <p:pic>
+        <p:nvPicPr>
+          <p:cNvPr id="2" name="Picture 1" descr="image.png"/>
+          <p:cNvPicPr>
+            <a:picLocks noChangeAspect="1"/>
+          </p:cNvPicPr>
+          <p:nvPr/>
+        </p:nvPicPr>
+        <p:blipFill>
+          <a:blip r:embed="rId2"/>
+          <a:stretch>
+            <a:fillRect/>
+          </a:stretch>
+        </p:blipFill>
+        <p:spPr>
+          <a:xfrm>
+            <a:off x="0" y="0"/>
+            <a:ext cx="9144000" cy="5143500"/>
+          </a:xfrm>
+          <a:prstGeom prst="rect">
+            <a:avLst/>
+          </a:prstGeom>
+        </p:spPr>
+      </p:pic>
+      <p:sp>
+        <p:nvSpPr>
+          <p:cNvPr id="3" name="Rectangle 2"/>
+          <p:cNvSpPr/>
+          <p:nvPr/>
+        </p:nvSpPr>
+        <p:spPr>
+          <a:xfrm>
+            <a:off x="0" y="640080"/>
+            <a:ext cx="91440" cy="329184"/>
+          </a:xfrm>
+          <a:prstGeom prst="rect">
+            <a:avLst/>
+          </a:prstGeom>
+          <a:solidFill>
+            <a:srgbClr val="29B5E8"/>
+          </a:solidFill>
+          <a:ln>
+            <a:noFill/>
+          </a:ln>
+          <a:effectLst/>
+        </p:spPr>
+        <p:style>
+          <a:lnRef idx="1">
+            <a:schemeClr val="accent1"/>
+          </a:lnRef>
+          <a:fillRef idx="3">
+            <a:schemeClr val="accent1"/>
+          </a:fillRef>
+          <a:effectRef idx="2">
+            <a:schemeClr val="accent1"/>
+          </a:effectRef>
+          <a:fontRef idx="minor">
+            <a:schemeClr val="lt1"/>
+          </a:fontRef>
+        </p:style>
+        <p:txBody>
+          <a:bodyPr rtlCol="0" anchor="ctr"/>
+          <a:lstStyle/>
+          <a:p>
+            <a:pPr algn="ctr"/>
+          </a:p>
+        </p:txBody>
+      </p:sp>
+      <p:sp>
+        <p:nvSpPr>
+          <p:cNvPr id="4" name="TextBox 3"/>
+          <p:cNvSpPr txBox="1"/>
+          <p:nvPr/>
+        </p:nvSpPr>
+        <p:spPr>
+          <a:xfrm>
+            <a:off x="411480" y="603504"/>
+            <a:ext cx="8321040" cy="384048"/>
+          </a:xfrm>
+          <a:prstGeom prst="rect">
+            <a:avLst/>
+          </a:prstGeom>
+          <a:noFill/>
+        </p:spPr>
+        <p:txBody>
+          <a:bodyPr wrap="square" lIns="0" rIns="0" tIns="0" bIns="0" anchor="t">
+            <a:spAutoFit/>
+          </a:bodyPr>
+          <a:lstStyle/>
+          <a:p>
+            <a:pPr algn="l"/>
+            <a:r>
+              <a:rPr sz="2400" b="1" i="0">
+                <a:solidFill>
+                  <a:srgbClr val="000000"/>
+                </a:solidFill>
+                <a:latin typeface="Arial"/>
+              </a:rPr>
+              <a:t>Extend it from CoCo CLI: one brief, four approvals</a:t>
+            </a:r>
+          </a:p>
+        </p:txBody>
+      </p:sp>
+      <p:sp>
+        <p:nvSpPr>
+          <p:cNvPr id="5" name="TextBox 4"/>
+          <p:cNvSpPr txBox="1"/>
+          <p:nvPr/>
+        </p:nvSpPr>
+        <p:spPr>
+          <a:xfrm>
+            <a:off x="411480" y="987552"/>
+            <a:ext cx="8321040" cy="274320"/>
+          </a:xfrm>
+          <a:prstGeom prst="rect">
+            <a:avLst/>
+          </a:prstGeom>
+          <a:noFill/>
+        </p:spPr>
+        <p:txBody>
+          <a:bodyPr wrap="square" lIns="0" rIns="0" tIns="0" bIns="0" anchor="t">
+            <a:spAutoFit/>
+          </a:bodyPr>
+          <a:lstStyle/>
+          <a:p>
+            <a:pPr algn="l"/>
+            <a:r>
+              <a:rPr sz="1200" b="0" i="0">
+                <a:solidFill>
+                  <a:srgbClr val="5B5B5B"/>
+                </a:solidFill>
+                <a:latin typeface="Arial"/>
+              </a:rPr>
+              <a:t>An orchestrator skill and five subagents do the work. Snowflake enforces the bounds, not the prompt.</a:t>
+            </a:r>
+          </a:p>
+        </p:txBody>
+      </p:sp>
+      <p:pic>
+        <p:nvPicPr>
+          <p:cNvPr id="6" name="Picture 5" descr="09-usecase-studio.png"/>
+          <p:cNvPicPr>
+            <a:picLocks noChangeAspect="1"/>
+          </p:cNvPicPr>
+          <p:nvPr/>
+        </p:nvPicPr>
+        <p:blipFill>
+          <a:blip r:embed="rId3"/>
+          <a:stretch>
+            <a:fillRect/>
+          </a:stretch>
+        </p:blipFill>
+        <p:spPr>
+          <a:xfrm>
+            <a:off x="571500" y="1298448"/>
+            <a:ext cx="8001000" cy="3652630"/>
+          </a:xfrm>
+          <a:prstGeom prst="rect">
+            <a:avLst/>
+          </a:prstGeom>
+        </p:spPr>
+      </p:pic>
+    </p:spTree>
+  </p:cSld>
+  <p:clrMapOvr>
+    <a:masterClrMapping/>
+  </p:clrMapOvr>
+</p:sld>
+</file>
+
+<file path=ppt/slides/slide18.xml><?xml version="1.0" encoding="utf-8"?>
+<p:sld xmlns:a="http://schemas.openxmlformats.org/drawingml/2006/main" xmlns:p="http://schemas.openxmlformats.org/presentationml/2006/main" xmlns:r="http://schemas.openxmlformats.org/officeDocument/2006/relationships">
+  <p:cSld>
+    <p:spTree>
+      <p:nvGrpSpPr>
+        <p:cNvPr id="1" name=""/>
+        <p:cNvGrpSpPr/>
+        <p:nvPr/>
+      </p:nvGrpSpPr>
+      <p:grpSpPr/>
+      <p:pic>
+        <p:nvPicPr>
+          <p:cNvPr id="2" name="Picture 1" descr="image.png"/>
+          <p:cNvPicPr>
+            <a:picLocks noChangeAspect="1"/>
+          </p:cNvPicPr>
+          <p:nvPr/>
+        </p:nvPicPr>
+        <p:blipFill>
+          <a:blip r:embed="rId2"/>
+          <a:stretch>
+            <a:fillRect/>
+          </a:stretch>
+        </p:blipFill>
+        <p:spPr>
+          <a:xfrm>
+            <a:off x="0" y="0"/>
+            <a:ext cx="9144000" cy="5143500"/>
+          </a:xfrm>
+          <a:prstGeom prst="rect">
+            <a:avLst/>
+          </a:prstGeom>
+        </p:spPr>
+      </p:pic>
+      <p:sp>
+        <p:nvSpPr>
+          <p:cNvPr id="3" name="Rectangle 2"/>
+          <p:cNvSpPr/>
+          <p:nvPr/>
+        </p:nvSpPr>
+        <p:spPr>
+          <a:xfrm>
+            <a:off x="0" y="640080"/>
+            <a:ext cx="91440" cy="329184"/>
+          </a:xfrm>
+          <a:prstGeom prst="rect">
+            <a:avLst/>
+          </a:prstGeom>
+          <a:solidFill>
+            <a:srgbClr val="29B5E8"/>
+          </a:solidFill>
+          <a:ln>
+            <a:noFill/>
+          </a:ln>
+          <a:effectLst/>
+        </p:spPr>
+        <p:style>
+          <a:lnRef idx="1">
+            <a:schemeClr val="accent1"/>
+          </a:lnRef>
+          <a:fillRef idx="3">
+            <a:schemeClr val="accent1"/>
+          </a:fillRef>
+          <a:effectRef idx="2">
+            <a:schemeClr val="accent1"/>
+          </a:effectRef>
+          <a:fontRef idx="minor">
+            <a:schemeClr val="lt1"/>
+          </a:fontRef>
+        </p:style>
+        <p:txBody>
+          <a:bodyPr rtlCol="0" anchor="ctr"/>
+          <a:lstStyle/>
+          <a:p>
+            <a:pPr algn="ctr"/>
+          </a:p>
+        </p:txBody>
+      </p:sp>
+      <p:sp>
+        <p:nvSpPr>
+          <p:cNvPr id="4" name="TextBox 3"/>
+          <p:cNvSpPr txBox="1"/>
+          <p:nvPr/>
+        </p:nvSpPr>
+        <p:spPr>
+          <a:xfrm>
+            <a:off x="411480" y="603504"/>
+            <a:ext cx="8321040" cy="384048"/>
+          </a:xfrm>
+          <a:prstGeom prst="rect">
+            <a:avLst/>
+          </a:prstGeom>
+          <a:noFill/>
+        </p:spPr>
+        <p:txBody>
+          <a:bodyPr wrap="square" lIns="0" rIns="0" tIns="0" bIns="0" anchor="t">
+            <a:spAutoFit/>
+          </a:bodyPr>
+          <a:lstStyle/>
+          <a:p>
+            <a:pPr algn="l"/>
+            <a:r>
+              <a:rPr sz="2400" b="1" i="0">
+                <a:solidFill>
+                  <a:srgbClr val="000000"/>
+                </a:solidFill>
+                <a:latin typeface="Arial"/>
+              </a:rPr>
+              <a:t>One brief to a live use case, safely</a:t>
+            </a:r>
+          </a:p>
+        </p:txBody>
+      </p:sp>
+      <p:sp>
+        <p:nvSpPr>
+          <p:cNvPr id="5" name="TextBox 4"/>
+          <p:cNvSpPr txBox="1"/>
+          <p:nvPr/>
+        </p:nvSpPr>
+        <p:spPr>
+          <a:xfrm>
+            <a:off x="411480" y="987552"/>
+            <a:ext cx="8321040" cy="274320"/>
+          </a:xfrm>
+          <a:prstGeom prst="rect">
+            <a:avLst/>
+          </a:prstGeom>
+          <a:noFill/>
+        </p:spPr>
+        <p:txBody>
+          <a:bodyPr wrap="square" lIns="0" rIns="0" tIns="0" bIns="0" anchor="t">
+            <a:spAutoFit/>
+          </a:bodyPr>
+          <a:lstStyle/>
+          <a:p>
+            <a:pPr algn="l"/>
+            <a:r>
+              <a:rPr sz="1200" b="0" i="0">
+                <a:solidFill>
+                  <a:srgbClr val="5B5B5B"/>
+                </a:solidFill>
+                <a:latin typeface="Arial"/>
+              </a:rPr>
+              <a:t>Life-Event Cover Upgrade, built on this book. The expert typed one sentence and approved four gates.</a:t>
+            </a:r>
+          </a:p>
+        </p:txBody>
+      </p:sp>
+      <p:sp>
+        <p:nvSpPr>
+          <p:cNvPr id="6" name="Rounded Rectangle 5"/>
+          <p:cNvSpPr/>
+          <p:nvPr/>
+        </p:nvSpPr>
+        <p:spPr>
+          <a:xfrm>
+            <a:off x="411480" y="1371600"/>
+            <a:ext cx="1977390" cy="2514600"/>
+          </a:xfrm>
+          <a:prstGeom prst="roundRect">
+            <a:avLst>
+              <a:gd name="adj" fmla="val 8000"/>
+            </a:avLst>
+          </a:prstGeom>
+          <a:solidFill>
+            <a:srgbClr val="E3EDF4"/>
+          </a:solidFill>
+          <a:ln>
+            <a:noFill/>
+          </a:ln>
+          <a:effectLst/>
+        </p:spPr>
+        <p:style>
+          <a:lnRef idx="1">
+            <a:schemeClr val="accent1"/>
+          </a:lnRef>
+          <a:fillRef idx="3">
+            <a:schemeClr val="accent1"/>
+          </a:fillRef>
+          <a:effectRef idx="2">
+            <a:schemeClr val="accent1"/>
+          </a:effectRef>
+          <a:fontRef idx="minor">
+            <a:schemeClr val="lt1"/>
+          </a:fontRef>
+        </p:style>
+        <p:txBody>
+          <a:bodyPr rtlCol="0" anchor="ctr"/>
+          <a:lstStyle/>
+          <a:p>
+            <a:pPr algn="ctr"/>
+          </a:p>
+        </p:txBody>
+      </p:sp>
+      <p:sp>
+        <p:nvSpPr>
+          <p:cNvPr id="7" name="TextBox 6"/>
+          <p:cNvSpPr txBox="1"/>
+          <p:nvPr/>
+        </p:nvSpPr>
+        <p:spPr>
+          <a:xfrm>
+            <a:off x="576072" y="1517904"/>
+            <a:ext cx="1703070" cy="228600"/>
+          </a:xfrm>
+          <a:prstGeom prst="rect">
+            <a:avLst/>
+          </a:prstGeom>
+          <a:noFill/>
+        </p:spPr>
+        <p:txBody>
+          <a:bodyPr wrap="square" lIns="0" rIns="0" tIns="0" bIns="0" anchor="t">
+            <a:spAutoFit/>
+          </a:bodyPr>
+          <a:lstStyle/>
+          <a:p>
+            <a:pPr algn="l"/>
+            <a:r>
+              <a:rPr sz="950" b="1" i="0">
+                <a:solidFill>
+                  <a:srgbClr val="5B5B5B"/>
+                </a:solidFill>
+                <a:latin typeface="Arial"/>
+              </a:rPr>
+              <a:t>G1 · PLAN</a:t>
+            </a:r>
+          </a:p>
+        </p:txBody>
+      </p:sp>
+      <p:sp>
+        <p:nvSpPr>
+          <p:cNvPr id="8" name="TextBox 7"/>
+          <p:cNvSpPr txBox="1"/>
+          <p:nvPr/>
+        </p:nvSpPr>
+        <p:spPr>
+          <a:xfrm>
+            <a:off x="576072" y="1810512"/>
+            <a:ext cx="1703070" cy="502920"/>
+          </a:xfrm>
+          <a:prstGeom prst="rect">
+            <a:avLst/>
+          </a:prstGeom>
+          <a:noFill/>
+        </p:spPr>
+        <p:txBody>
+          <a:bodyPr wrap="square" lIns="0" rIns="0" tIns="0" bIns="0" anchor="t">
+            <a:spAutoFit/>
+          </a:bodyPr>
+          <a:lstStyle/>
+          <a:p>
+            <a:pPr algn="l"/>
+            <a:r>
+              <a:rPr sz="2400" b="1" i="0">
+                <a:solidFill>
+                  <a:srgbClr val="252525"/>
+                </a:solidFill>
+                <a:latin typeface="Arial"/>
+              </a:rPr>
+              <a:t>6 + 2</a:t>
+            </a:r>
+          </a:p>
+        </p:txBody>
+      </p:sp>
+      <p:sp>
+        <p:nvSpPr>
+          <p:cNvPr id="9" name="TextBox 8"/>
+          <p:cNvSpPr txBox="1"/>
+          <p:nvPr/>
+        </p:nvSpPr>
+        <p:spPr>
+          <a:xfrm>
+            <a:off x="576072" y="2395728"/>
+            <a:ext cx="1703070" cy="1417320"/>
+          </a:xfrm>
+          <a:prstGeom prst="rect">
+            <a:avLst/>
+          </a:prstGeom>
+          <a:noFill/>
+        </p:spPr>
+        <p:txBody>
+          <a:bodyPr wrap="square" lIns="0" rIns="0" tIns="0" bIns="0" anchor="t">
+            <a:spAutoFit/>
+          </a:bodyPr>
+          <a:lstStyle/>
+          <a:p>
+            <a:pPr algn="l"/>
+            <a:r>
+              <a:rPr sz="1150" b="0" i="0">
+                <a:solidFill>
+                  <a:srgbClr val="252525"/>
+                </a:solidFill>
+                <a:latin typeface="Arial"/>
+              </a:rPr>
+              <a:t>6 signals reused, 2 built: cover gap from policy and claims records, life event from what customers said.</a:t>
+            </a:r>
+          </a:p>
+        </p:txBody>
+      </p:sp>
+      <p:sp>
+        <p:nvSpPr>
+          <p:cNvPr id="10" name="Rounded Rectangle 9"/>
+          <p:cNvSpPr/>
+          <p:nvPr/>
+        </p:nvSpPr>
+        <p:spPr>
+          <a:xfrm>
+            <a:off x="2526030" y="1371600"/>
+            <a:ext cx="1977390" cy="2514600"/>
+          </a:xfrm>
+          <a:prstGeom prst="roundRect">
+            <a:avLst>
+              <a:gd name="adj" fmla="val 8000"/>
+            </a:avLst>
+          </a:prstGeom>
+          <a:solidFill>
+            <a:srgbClr val="E3F6F7"/>
+          </a:solidFill>
+          <a:ln>
+            <a:noFill/>
+          </a:ln>
+          <a:effectLst/>
+        </p:spPr>
+        <p:style>
+          <a:lnRef idx="1">
+            <a:schemeClr val="accent1"/>
+          </a:lnRef>
+          <a:fillRef idx="3">
+            <a:schemeClr val="accent1"/>
+          </a:fillRef>
+          <a:effectRef idx="2">
+            <a:schemeClr val="accent1"/>
+          </a:effectRef>
+          <a:fontRef idx="minor">
+            <a:schemeClr val="lt1"/>
+          </a:fontRef>
+        </p:style>
+        <p:txBody>
+          <a:bodyPr rtlCol="0" anchor="ctr"/>
+          <a:lstStyle/>
+          <a:p>
+            <a:pPr algn="ctr"/>
+          </a:p>
+        </p:txBody>
+      </p:sp>
+      <p:sp>
+        <p:nvSpPr>
+          <p:cNvPr id="11" name="TextBox 10"/>
+          <p:cNvSpPr txBox="1"/>
+          <p:nvPr/>
+        </p:nvSpPr>
+        <p:spPr>
+          <a:xfrm>
+            <a:off x="2690622" y="1517904"/>
+            <a:ext cx="1703070" cy="228600"/>
+          </a:xfrm>
+          <a:prstGeom prst="rect">
+            <a:avLst/>
+          </a:prstGeom>
+          <a:noFill/>
+        </p:spPr>
+        <p:txBody>
+          <a:bodyPr wrap="square" lIns="0" rIns="0" tIns="0" bIns="0" anchor="t">
+            <a:spAutoFit/>
+          </a:bodyPr>
+          <a:lstStyle/>
+          <a:p>
+            <a:pPr algn="l"/>
+            <a:r>
+              <a:rPr sz="950" b="1" i="0">
+                <a:solidFill>
+                  <a:srgbClr val="5B5B5B"/>
+                </a:solidFill>
+                <a:latin typeface="Arial"/>
+              </a:rPr>
+              <a:t>G2 · SIGNALS</a:t>
+            </a:r>
+          </a:p>
+        </p:txBody>
+      </p:sp>
+      <p:sp>
+        <p:nvSpPr>
+          <p:cNvPr id="12" name="TextBox 11"/>
+          <p:cNvSpPr txBox="1"/>
+          <p:nvPr/>
+        </p:nvSpPr>
+        <p:spPr>
+          <a:xfrm>
+            <a:off x="2690622" y="1810512"/>
+            <a:ext cx="1703070" cy="502920"/>
+          </a:xfrm>
+          <a:prstGeom prst="rect">
+            <a:avLst/>
+          </a:prstGeom>
+          <a:noFill/>
+        </p:spPr>
+        <p:txBody>
+          <a:bodyPr wrap="square" lIns="0" rIns="0" tIns="0" bIns="0" anchor="t">
+            <a:spAutoFit/>
+          </a:bodyPr>
+          <a:lstStyle/>
+          <a:p>
+            <a:pPr algn="l"/>
+            <a:r>
+              <a:rPr sz="2400" b="1" i="0">
+                <a:solidFill>
+                  <a:srgbClr val="11567F"/>
+                </a:solidFill>
+                <a:latin typeface="Arial"/>
+              </a:rPr>
+              <a:t>0.46 → 0.83</a:t>
+            </a:r>
+          </a:p>
+        </p:txBody>
+      </p:sp>
+      <p:sp>
+        <p:nvSpPr>
+          <p:cNvPr id="13" name="TextBox 12"/>
+          <p:cNvSpPr txBox="1"/>
+          <p:nvPr/>
+        </p:nvSpPr>
+        <p:spPr>
+          <a:xfrm>
+            <a:off x="2690622" y="2395728"/>
+            <a:ext cx="1703070" cy="1417320"/>
+          </a:xfrm>
+          <a:prstGeom prst="rect">
+            <a:avLst/>
+          </a:prstGeom>
+          <a:noFill/>
+        </p:spPr>
+        <p:txBody>
+          <a:bodyPr wrap="square" lIns="0" rIns="0" tIns="0" bIns="0" anchor="t">
+            <a:spAutoFit/>
+          </a:bodyPr>
+          <a:lstStyle/>
+          <a:p>
+            <a:pPr algn="l"/>
+            <a:r>
+              <a:rPr sz="1150" b="0" i="0">
+                <a:solidFill>
+                  <a:srgbClr val="252525"/>
+                </a:solidFill>
+                <a:latin typeface="Arial"/>
+              </a:rPr>
+              <a:t>Precision of the life-event signal (95% CI 0.72–0.91). The builder fixed its own definitions.</a:t>
+            </a:r>
+          </a:p>
+        </p:txBody>
+      </p:sp>
+      <p:sp>
+        <p:nvSpPr>
+          <p:cNvPr id="14" name="Rounded Rectangle 13"/>
+          <p:cNvSpPr/>
+          <p:nvPr/>
+        </p:nvSpPr>
+        <p:spPr>
+          <a:xfrm>
+            <a:off x="4640580" y="1371600"/>
+            <a:ext cx="1977390" cy="2514600"/>
+          </a:xfrm>
+          <a:prstGeom prst="roundRect">
+            <a:avLst>
+              <a:gd name="adj" fmla="val 8000"/>
+            </a:avLst>
+          </a:prstGeom>
+          <a:solidFill>
+            <a:srgbClr val="EEEAF5"/>
+          </a:solidFill>
+          <a:ln>
+            <a:noFill/>
+          </a:ln>
+          <a:effectLst/>
+        </p:spPr>
+        <p:style>
+          <a:lnRef idx="1">
+            <a:schemeClr val="accent1"/>
+          </a:lnRef>
+          <a:fillRef idx="3">
+            <a:schemeClr val="accent1"/>
+          </a:fillRef>
+          <a:effectRef idx="2">
+            <a:schemeClr val="accent1"/>
+          </a:effectRef>
+          <a:fontRef idx="minor">
+            <a:schemeClr val="lt1"/>
+          </a:fontRef>
+        </p:style>
+        <p:txBody>
+          <a:bodyPr rtlCol="0" anchor="ctr"/>
+          <a:lstStyle/>
+          <a:p>
+            <a:pPr algn="ctr"/>
+          </a:p>
+        </p:txBody>
+      </p:sp>
+      <p:sp>
+        <p:nvSpPr>
+          <p:cNvPr id="15" name="TextBox 14"/>
+          <p:cNvSpPr txBox="1"/>
+          <p:nvPr/>
+        </p:nvSpPr>
+        <p:spPr>
+          <a:xfrm>
+            <a:off x="4805172" y="1517904"/>
+            <a:ext cx="1703070" cy="228600"/>
+          </a:xfrm>
+          <a:prstGeom prst="rect">
+            <a:avLst/>
+          </a:prstGeom>
+          <a:noFill/>
+        </p:spPr>
+        <p:txBody>
+          <a:bodyPr wrap="square" lIns="0" rIns="0" tIns="0" bIns="0" anchor="t">
+            <a:spAutoFit/>
+          </a:bodyPr>
+          <a:lstStyle/>
+          <a:p>
+            <a:pPr algn="l"/>
+            <a:r>
+              <a:rPr sz="950" b="1" i="0">
+                <a:solidFill>
+                  <a:srgbClr val="5B5B5B"/>
+                </a:solidFill>
+                <a:latin typeface="Arial"/>
+              </a:rPr>
+              <a:t>G3 · SIMULATE</a:t>
+            </a:r>
+          </a:p>
+        </p:txBody>
+      </p:sp>
+      <p:sp>
+        <p:nvSpPr>
+          <p:cNvPr id="16" name="TextBox 15"/>
+          <p:cNvSpPr txBox="1"/>
+          <p:nvPr/>
+        </p:nvSpPr>
+        <p:spPr>
+          <a:xfrm>
+            <a:off x="4805172" y="1810512"/>
+            <a:ext cx="1703070" cy="502920"/>
+          </a:xfrm>
+          <a:prstGeom prst="rect">
+            <a:avLst/>
+          </a:prstGeom>
+          <a:noFill/>
+        </p:spPr>
+        <p:txBody>
+          <a:bodyPr wrap="square" lIns="0" rIns="0" tIns="0" bIns="0" anchor="t">
+            <a:spAutoFit/>
+          </a:bodyPr>
+          <a:lstStyle/>
+          <a:p>
+            <a:pPr algn="l"/>
+            <a:r>
+              <a:rPr sz="2400" b="1" i="0">
+                <a:solidFill>
+                  <a:srgbClr val="252525"/>
+                </a:solidFill>
+                <a:latin typeface="Arial"/>
+              </a:rPr>
+              <a:t>147</a:t>
+            </a:r>
+          </a:p>
+        </p:txBody>
+      </p:sp>
+      <p:sp>
+        <p:nvSpPr>
+          <p:cNvPr id="17" name="TextBox 16"/>
+          <p:cNvSpPr txBox="1"/>
+          <p:nvPr/>
+        </p:nvSpPr>
+        <p:spPr>
+          <a:xfrm>
+            <a:off x="4805172" y="2395728"/>
+            <a:ext cx="1703070" cy="1417320"/>
+          </a:xfrm>
+          <a:prstGeom prst="rect">
+            <a:avLst/>
+          </a:prstGeom>
+          <a:noFill/>
+        </p:spPr>
+        <p:txBody>
+          <a:bodyPr wrap="square" lIns="0" rIns="0" tIns="0" bIns="0" anchor="t">
+            <a:spAutoFit/>
+          </a:bodyPr>
+          <a:lstStyle/>
+          <a:p>
+            <a:pPr algn="l"/>
+            <a:r>
+              <a:rPr sz="1150" b="0" i="0">
+                <a:solidFill>
+                  <a:srgbClr val="252525"/>
+                </a:solidFill>
+                <a:latin typeface="Arial"/>
+              </a:rPr>
+              <a:t>customers reached of 261 matched; 114 held back by risk or guardrail; 0 violations. An off-catalog offer was refused.</a:t>
+            </a:r>
+          </a:p>
+        </p:txBody>
+      </p:sp>
+      <p:sp>
+        <p:nvSpPr>
+          <p:cNvPr id="18" name="Rounded Rectangle 17"/>
+          <p:cNvSpPr/>
+          <p:nvPr/>
+        </p:nvSpPr>
+        <p:spPr>
+          <a:xfrm>
+            <a:off x="6755130" y="1371600"/>
+            <a:ext cx="1977390" cy="2514600"/>
+          </a:xfrm>
+          <a:prstGeom prst="roundRect">
+            <a:avLst>
+              <a:gd name="adj" fmla="val 8000"/>
+            </a:avLst>
+          </a:prstGeom>
+          <a:solidFill>
+            <a:srgbClr val="DDF2FB"/>
+          </a:solidFill>
+          <a:ln>
+            <a:noFill/>
+          </a:ln>
+          <a:effectLst/>
+        </p:spPr>
+        <p:style>
+          <a:lnRef idx="1">
+            <a:schemeClr val="accent1"/>
+          </a:lnRef>
+          <a:fillRef idx="3">
+            <a:schemeClr val="accent1"/>
+          </a:fillRef>
+          <a:effectRef idx="2">
+            <a:schemeClr val="accent1"/>
+          </a:effectRef>
+          <a:fontRef idx="minor">
+            <a:schemeClr val="lt1"/>
+          </a:fontRef>
+        </p:style>
+        <p:txBody>
+          <a:bodyPr rtlCol="0" anchor="ctr"/>
+          <a:lstStyle/>
+          <a:p>
+            <a:pPr algn="ctr"/>
+          </a:p>
+        </p:txBody>
+      </p:sp>
+      <p:sp>
+        <p:nvSpPr>
+          <p:cNvPr id="19" name="TextBox 18"/>
+          <p:cNvSpPr txBox="1"/>
+          <p:nvPr/>
+        </p:nvSpPr>
+        <p:spPr>
+          <a:xfrm>
+            <a:off x="6919722" y="1517904"/>
+            <a:ext cx="1703070" cy="228600"/>
+          </a:xfrm>
+          <a:prstGeom prst="rect">
+            <a:avLst/>
+          </a:prstGeom>
+          <a:noFill/>
+        </p:spPr>
+        <p:txBody>
+          <a:bodyPr wrap="square" lIns="0" rIns="0" tIns="0" bIns="0" anchor="t">
+            <a:spAutoFit/>
+          </a:bodyPr>
+          <a:lstStyle/>
+          <a:p>
+            <a:pPr algn="l"/>
+            <a:r>
+              <a:rPr sz="950" b="1" i="0">
+                <a:solidFill>
+                  <a:srgbClr val="5B5B5B"/>
+                </a:solidFill>
+                <a:latin typeface="Arial"/>
+              </a:rPr>
+              <a:t>G4 · RELEASE</a:t>
+            </a:r>
+          </a:p>
+        </p:txBody>
+      </p:sp>
+      <p:sp>
+        <p:nvSpPr>
+          <p:cNvPr id="20" name="TextBox 19"/>
+          <p:cNvSpPr txBox="1"/>
+          <p:nvPr/>
+        </p:nvSpPr>
+        <p:spPr>
+          <a:xfrm>
+            <a:off x="6919722" y="1810512"/>
+            <a:ext cx="1703070" cy="502920"/>
+          </a:xfrm>
+          <a:prstGeom prst="rect">
+            <a:avLst/>
+          </a:prstGeom>
+          <a:noFill/>
+        </p:spPr>
+        <p:txBody>
+          <a:bodyPr wrap="square" lIns="0" rIns="0" tIns="0" bIns="0" anchor="t">
+            <a:spAutoFit/>
+          </a:bodyPr>
+          <a:lstStyle/>
+          <a:p>
+            <a:pPr algn="l"/>
+            <a:r>
+              <a:rPr sz="2400" b="1" i="0">
+                <a:solidFill>
+                  <a:srgbClr val="11567F"/>
+                </a:solidFill>
+                <a:latin typeface="Arial"/>
+              </a:rPr>
+              <a:t>19 rows</a:t>
+            </a:r>
+          </a:p>
+        </p:txBody>
+      </p:sp>
+      <p:sp>
+        <p:nvSpPr>
+          <p:cNvPr id="21" name="TextBox 20"/>
+          <p:cNvSpPr txBox="1"/>
+          <p:nvPr/>
+        </p:nvSpPr>
+        <p:spPr>
+          <a:xfrm>
+            <a:off x="6919722" y="2395728"/>
+            <a:ext cx="1703070" cy="1417320"/>
+          </a:xfrm>
+          <a:prstGeom prst="rect">
+            <a:avLst/>
+          </a:prstGeom>
+          <a:noFill/>
+        </p:spPr>
+        <p:txBody>
+          <a:bodyPr wrap="square" lIns="0" rIns="0" tIns="0" bIns="0" anchor="t">
+            <a:spAutoFit/>
+          </a:bodyPr>
+          <a:lstStyle/>
+          <a:p>
+            <a:pPr algn="l"/>
+            <a:r>
+              <a:rPr sz="1150" b="0" i="0">
+                <a:solidFill>
+                  <a:srgbClr val="252525"/>
+                </a:solidFill>
+                <a:latin typeface="Arial"/>
+              </a:rPr>
+              <a:t>Version 1 live, no engine code. Rolls back in one call.</a:t>
+            </a:r>
+          </a:p>
+        </p:txBody>
+      </p:sp>
+      <p:sp>
+        <p:nvSpPr>
+          <p:cNvPr id="22" name="Rounded Rectangle 21"/>
+          <p:cNvSpPr/>
+          <p:nvPr/>
+        </p:nvSpPr>
+        <p:spPr>
+          <a:xfrm>
+            <a:off x="411480" y="4023360"/>
+            <a:ext cx="8321040" cy="749808"/>
+          </a:xfrm>
+          <a:prstGeom prst="roundRect">
+            <a:avLst>
+              <a:gd name="adj" fmla="val 8000"/>
+            </a:avLst>
+          </a:prstGeom>
+          <a:solidFill>
+            <a:srgbClr val="EAF2F7"/>
+          </a:solidFill>
+          <a:ln>
+            <a:noFill/>
+          </a:ln>
+          <a:effectLst/>
+        </p:spPr>
+        <p:style>
+          <a:lnRef idx="1">
+            <a:schemeClr val="accent1"/>
+          </a:lnRef>
+          <a:fillRef idx="3">
+            <a:schemeClr val="accent1"/>
+          </a:fillRef>
+          <a:effectRef idx="2">
+            <a:schemeClr val="accent1"/>
+          </a:effectRef>
+          <a:fontRef idx="minor">
+            <a:schemeClr val="lt1"/>
+          </a:fontRef>
+        </p:style>
+        <p:txBody>
+          <a:bodyPr rtlCol="0" anchor="ctr"/>
+          <a:lstStyle/>
+          <a:p>
+            <a:pPr algn="ctr"/>
+          </a:p>
+        </p:txBody>
+      </p:sp>
+      <p:sp>
+        <p:nvSpPr>
+          <p:cNvPr id="23" name="TextBox 22"/>
+          <p:cNvSpPr txBox="1"/>
+          <p:nvPr/>
+        </p:nvSpPr>
+        <p:spPr>
+          <a:xfrm>
+            <a:off x="621792" y="4023360"/>
+            <a:ext cx="7955279" cy="749808"/>
+          </a:xfrm>
+          <a:prstGeom prst="rect">
+            <a:avLst/>
+          </a:prstGeom>
+          <a:noFill/>
+        </p:spPr>
+        <p:txBody>
+          <a:bodyPr wrap="square" lIns="0" rIns="0" tIns="0" bIns="0" anchor="ctr">
+            <a:spAutoFit/>
+          </a:bodyPr>
+          <a:lstStyle/>
+          <a:p>
+            <a:pPr algn="l"/>
+            <a:r>
+              <a:rPr sz="1150" b="1" i="0">
+                <a:solidFill>
+                  <a:srgbClr val="252525"/>
+                </a:solidFill>
+                <a:latin typeface="Arial"/>
+              </a:rPr>
+              <a:t>Then change it.  </a:t>
+            </a:r>
+            <a:r>
+              <a:rPr sz="1150" b="0" i="0">
+                <a:solidFill>
+                  <a:srgbClr val="252525"/>
+                </a:solidFill>
+                <a:latin typeface="Arial"/>
+              </a:rPr>
+              <a:t>Tuning shows before/after (147 → 99 reached, nobody else's offer changed). Ask for something unsafe and Snowflake refuses it: weights are capped, guardrails can't be removed, approvals are bound to the exact draft.</a:t>
+            </a:r>
+          </a:p>
+        </p:txBody>
+      </p:sp>
+    </p:spTree>
+  </p:cSld>
+  <p:clrMapOvr>
+    <a:masterClrMapping/>
+  </p:clrMapOvr>
+</p:sld>
+</file>
+
+<file path=ppt/slides/slide19.xml><?xml version="1.0" encoding="utf-8"?>
 <p:sld xmlns:a="http://schemas.openxmlformats.org/drawingml/2006/main" xmlns:p="http://schemas.openxmlformats.org/presentationml/2006/main" xmlns:r="http://schemas.openxmlformats.org/officeDocument/2006/relationships">
   <p:cSld>
     <p:spTree>
@@ -21224,7 +22256,7 @@
                 </a:solidFill>
                 <a:latin typeface="Arial"/>
               </a:rPr>
-              <a:t>Built the platform and packages it as skills</a:t>
+              <a:t>Skills, subagents and hooks build and extend the platform</a:t>
             </a:r>
           </a:p>
         </p:txBody>
@@ -21237,7 +22269,7 @@
 </p:sld>
 </file>
 
-<file path=ppt/slides/slide18.xml><?xml version="1.0" encoding="utf-8"?>
+<file path=ppt/slides/slide20.xml><?xml version="1.0" encoding="utf-8"?>
 <p:sld xmlns:a="http://schemas.openxmlformats.org/drawingml/2006/main" xmlns:p="http://schemas.openxmlformats.org/presentationml/2006/main" xmlns:r="http://schemas.openxmlformats.org/officeDocument/2006/relationships">
   <p:cSld>
     <p:spTree>
@@ -23069,7 +24101,7 @@
 </p:sld>
 </file>
 
-<file path=ppt/slides/slide19.xml><?xml version="1.0" encoding="utf-8"?>
+<file path=ppt/slides/slide21.xml><?xml version="1.0" encoding="utf-8"?>
 <p:sld xmlns:a="http://schemas.openxmlformats.org/drawingml/2006/main" xmlns:p="http://schemas.openxmlformats.org/presentationml/2006/main" xmlns:r="http://schemas.openxmlformats.org/officeDocument/2006/relationships">
   <p:cSld>
     <p:spTree>
@@ -27102,7 +28134,7 @@
                 </a:solidFill>
                 <a:latin typeface="Arial"/>
               </a:rPr>
-              <a:t>Configuration-driven.  </a:t>
+              <a:t>Safe change, built in.  </a:t>
             </a:r>
             <a:r>
               <a:rPr sz="1200" b="0" i="0">
@@ -27111,7 +28143,7 @@
                 </a:solidFill>
                 <a:latin typeface="Arial"/>
               </a:rPr>
-              <a:t>Weights, limits, rules, signals and whole use cases change without a release.</a:t>
+              <a:t>New and changed use cases pass approval gates, a whole-book simulation and hard bounds, and roll back in one call.</a:t>
             </a:r>
           </a:p>
         </p:txBody>
@@ -27124,7 +28156,7 @@
 </p:sld>
 </file>
 
-<file path=ppt/slides/slide20.xml><?xml version="1.0" encoding="utf-8"?>
+<file path=ppt/slides/slide22.xml><?xml version="1.0" encoding="utf-8"?>
 <p:sld xmlns:a="http://schemas.openxmlformats.org/drawingml/2006/main" xmlns:p="http://schemas.openxmlformats.org/presentationml/2006/main" xmlns:r="http://schemas.openxmlformats.org/officeDocument/2006/relationships">
   <p:cSld>
     <p:spTree>
@@ -27806,7 +28838,7 @@
 </p:sld>
 </file>
 
-<file path=ppt/slides/slide21.xml><?xml version="1.0" encoding="utf-8"?>
+<file path=ppt/slides/slide23.xml><?xml version="1.0" encoding="utf-8"?>
 <p:sld xmlns:a="http://schemas.openxmlformats.org/drawingml/2006/main" xmlns:p="http://schemas.openxmlformats.org/presentationml/2006/main" xmlns:r="http://schemas.openxmlformats.org/officeDocument/2006/relationships">
   <p:cSld>
     <p:spTree>
@@ -27914,7 +28946,7 @@
                 </a:solidFill>
                 <a:latin typeface="Arial"/>
               </a:rPr>
-              <a:t>New use cases in days, new domains in weeks</a:t>
+              <a:t>New use cases in one session, new domains in weeks</a:t>
             </a:r>
           </a:p>
         </p:txBody>
@@ -27949,7 +28981,7 @@
                 </a:solidFill>
                 <a:latin typeface="Arial"/>
               </a:rPr>
-              <a:t>Everything above the data mapping is reused. A domain expert shapes the ontology; the platform does the rest.</a:t>
+              <a:t>CoCo builds use cases on existing data from a brief. For a new domain, an expert shapes the ontology; the rest is reused.</a:t>
             </a:r>
           </a:p>
         </p:txBody>
@@ -27986,7 +29018,7 @@
 </p:sld>
 </file>
 
-<file path=ppt/slides/slide22.xml><?xml version="1.0" encoding="utf-8"?>
+<file path=ppt/slides/slide24.xml><?xml version="1.0" encoding="utf-8"?>
 <p:sld xmlns:a="http://schemas.openxmlformats.org/drawingml/2006/main" xmlns:p="http://schemas.openxmlformats.org/presentationml/2006/main" xmlns:r="http://schemas.openxmlformats.org/officeDocument/2006/relationships">
   <p:cSld>
     <p:spTree>
@@ -31723,7 +32755,7 @@
 </p:sld>
 </file>
 
-<file path=ppt/slides/slide23.xml><?xml version="1.0" encoding="utf-8"?>
+<file path=ppt/slides/slide25.xml><?xml version="1.0" encoding="utf-8"?>
 <p:sld xmlns:a="http://schemas.openxmlformats.org/drawingml/2006/main" xmlns:p="http://schemas.openxmlformats.org/presentationml/2006/main" xmlns:r="http://schemas.openxmlformats.org/officeDocument/2006/relationships">
   <p:cSld>
     <p:spTree>
@@ -36359,7 +37391,7 @@
                 </a:solidFill>
                 <a:latin typeface="Arial"/>
               </a:rPr>
-              <a:t>AI onboarding wizard</a:t>
+              <a:t>AI onboarding wizard in Streamlit</a:t>
             </a:r>
           </a:p>
         </p:txBody>
@@ -36394,7 +37426,7 @@
                 </a:solidFill>
                 <a:latin typeface="Arial"/>
               </a:rPr>
-              <a:t>Describe a use case or signal in plain English. AI drafts the configuration and a person approves it.</a:t>
+              <a:t>The use-case studio as a guided screen in the app: describe a use case, review each gate, approve.</a:t>
             </a:r>
           </a:p>
         </p:txBody>
@@ -37701,7 +38733,7 @@
 </p:sld>
 </file>
 
-<file path=ppt/slides/slide24.xml><?xml version="1.0" encoding="utf-8"?>
+<file path=ppt/slides/slide26.xml><?xml version="1.0" encoding="utf-8"?>
 <p:sld xmlns:a="http://schemas.openxmlformats.org/drawingml/2006/main" xmlns:p="http://schemas.openxmlformats.org/presentationml/2006/main" xmlns:r="http://schemas.openxmlformats.org/officeDocument/2006/relationships">
   <p:cSld>
     <p:spTree>
@@ -44067,7 +45099,7 @@
                 </a:solidFill>
                 <a:latin typeface="Arial"/>
               </a:rPr>
-              <a:t>4</a:t>
+              <a:t>5 + 5</a:t>
             </a:r>
           </a:p>
         </p:txBody>
@@ -44102,7 +45134,7 @@
                 </a:solidFill>
                 <a:latin typeface="Arial"/>
               </a:rPr>
-              <a:t>reusable CoCo CLI skills</a:t>
+              <a:t>CoCo CLI skills and subagents</a:t>
             </a:r>
           </a:p>
         </p:txBody>

</xml_diff>

<commit_message>
feat: life-event use case built by the c360-usecase agents, live in RM feed
Generated with [Snowflake CoCo](https://docs.snowflake.com/en/user-guide/cortex-code/cortex-code)

Co-authored-by: Snowflake CoCo <noreply@snowflake.com>
</commit_message>
<xml_diff>
--- a/deck/Customer360_Decisioning_Platform_Snowflake.pptx
+++ b/deck/Customer360_Decisioning_Platform_Snowflake.pptx
@@ -11617,7 +11617,7 @@
                 </a:solidFill>
                 <a:latin typeface="Arial"/>
               </a:rPr>
-              <a:t>One brief to a live use case, safely</a:t>
+              <a:t>Life-Event Cover Upgrade, built by CoCo agents</a:t>
             </a:r>
           </a:p>
         </p:txBody>
@@ -11652,7 +11652,7 @@
                 </a:solidFill>
                 <a:latin typeface="Arial"/>
               </a:rPr>
-              <a:t>Life-Event Cover Upgrade, built on this book. The expert typed one sentence and approved four gates.</a:t>
+              <a:t>One CoCo skill and five subagents: one sentence from the expert, four approvals, live in an RM's feed.</a:t>
             </a:r>
           </a:p>
         </p:txBody>
@@ -11733,7 +11733,7 @@
                 </a:solidFill>
                 <a:latin typeface="Arial"/>
               </a:rPr>
-              <a:t>G1 · PLAN</a:t>
+              <a:t>G1 · SCOUT</a:t>
             </a:r>
           </a:p>
         </p:txBody>
@@ -11768,7 +11768,7 @@
                 </a:solidFill>
                 <a:latin typeface="Arial"/>
               </a:rPr>
-              <a:t>6 + 2</a:t>
+              <a:t>8 + 2</a:t>
             </a:r>
           </a:p>
         </p:txBody>
@@ -11803,7 +11803,7 @@
                 </a:solidFill>
                 <a:latin typeface="Arial"/>
               </a:rPr>
-              <a:t>6 signals reused, 2 built: cover gap from policy and claims records, life event from what customers said.</a:t>
+              <a:t>8 signals reused, 2 built: cover gap from policy and claims records, life event from what customers said.</a:t>
             </a:r>
           </a:p>
         </p:txBody>
@@ -11884,7 +11884,7 @@
                 </a:solidFill>
                 <a:latin typeface="Arial"/>
               </a:rPr>
-              <a:t>G2 · SIGNALS</a:t>
+              <a:t>G2 · SIGNAL BUILDER</a:t>
             </a:r>
           </a:p>
         </p:txBody>
@@ -11919,7 +11919,7 @@
                 </a:solidFill>
                 <a:latin typeface="Arial"/>
               </a:rPr>
-              <a:t>0.46 → 0.83</a:t>
+              <a:t>0.81 → 0.91</a:t>
             </a:r>
           </a:p>
         </p:txBody>
@@ -11954,7 +11954,7 @@
                 </a:solidFill>
                 <a:latin typeface="Arial"/>
               </a:rPr>
-              <a:t>Precision of the life-event signal (95% CI 0.72–0.91). The builder fixed its own definitions.</a:t>
+              <a:t>Precision of the life-event signal (95% CI 0.72–0.98). It tightened its own definitions and dropped a label it couldn't make reliable.</a:t>
             </a:r>
           </a:p>
         </p:txBody>
@@ -12035,7 +12035,7 @@
                 </a:solidFill>
                 <a:latin typeface="Arial"/>
               </a:rPr>
-              <a:t>G3 · SIMULATE</a:t>
+              <a:t>G3 · DESIGNER + SIMULATOR</a:t>
             </a:r>
           </a:p>
         </p:txBody>
@@ -12070,7 +12070,7 @@
                 </a:solidFill>
                 <a:latin typeface="Arial"/>
               </a:rPr>
-              <a:t>147</a:t>
+              <a:t>157</a:t>
             </a:r>
           </a:p>
         </p:txBody>
@@ -12105,7 +12105,7 @@
                 </a:solidFill>
                 <a:latin typeface="Arial"/>
               </a:rPr>
-              <a:t>customers reached of 261 matched; 114 held back by risk or guardrail; 0 violations. An off-catalog offer was refused.</a:t>
+              <a:t>customers reached of 278 matched; 121 held back. 3 conflicts with service recovery found and fixed; 0 violations.</a:t>
             </a:r>
           </a:p>
         </p:txBody>
@@ -12186,7 +12186,7 @@
                 </a:solidFill>
                 <a:latin typeface="Arial"/>
               </a:rPr>
-              <a:t>G4 · RELEASE</a:t>
+              <a:t>G4 · RELEASE MANAGER</a:t>
             </a:r>
           </a:p>
         </p:txBody>
@@ -12221,7 +12221,7 @@
                 </a:solidFill>
                 <a:latin typeface="Arial"/>
               </a:rPr>
-              <a:t>19 rows</a:t>
+              <a:t>23 rows</a:t>
             </a:r>
           </a:p>
         </p:txBody>
@@ -12256,7 +12256,7 @@
                 </a:solidFill>
                 <a:latin typeface="Arial"/>
               </a:rPr>
-              <a:t>Version 1 live, no engine code. Rolls back in one call.</a:t>
+              <a:t>Version 1 live, no engine code, already in an RM's feed. Rolls back in one call.</a:t>
             </a:r>
           </a:p>
         </p:txBody>
@@ -12346,7 +12346,7 @@
                 </a:solidFill>
                 <a:latin typeface="Arial"/>
               </a:rPr>
-              <a:t>Tuning shows before/after (147 → 99 reached, nobody else's offer changed). Ask for something unsafe and Snowflake refuses it: weights are capped, guardrails can't be removed, approvals are bound to the exact draft.</a:t>
+              <a:t>Tuning shows before/after: who gains, who loses, whose offer changes. Ask for something unsafe and Snowflake refuses it: weights are capped, guardrails can't be removed, approvals are bound to the exact draft.</a:t>
             </a:r>
           </a:p>
         </p:txBody>

</xml_diff>